<commit_message>
Add speaker notes, updated slides, and setup fixes
- docs: speaker notes for the slides, and Plan B notes for a live demo;
  updated slides and the guide builder that makes them
- requirements: pandas 3 or newer (cleaner.py uses its "str" text type),
  so setup now needs Python 3.11 or newer and rebuilds an older .venv
- setup waits longer and retries on slow internet
- guides point at the renamed repo, DA2009

Co-Authored-By: Claude Opus 5.5 <noreply@anthropic.com>
</commit_message>
<xml_diff>
--- a/docs/slides.pptx
+++ b/docs/slides.pptx
@@ -804,7 +804,8 @@
             <a:r>
               <a:rPr lang="en-US" dirty="0"/>
               <a:t>PRESENTED BY: 24ada076 - Nuhan (opening)
-Good morning. I'm Nuhan, and this is our DA 2009 group project: collecting data from the Colombo Stock Exchange website. Our group is Pasindu, Sasini, Salaama and me. I'll open, and my teammates will explain how it works.</a:t>
+Good morning. I'm Nuhan, and this is our DA 2009 group project: collecting data from the Colombo Stock Exchange website. Our group is Pasindu, Sasini, Salaama and me.
+I'll open, and my teammates will explain how it works.</a:t>
             </a:r>
             <a:endParaRPr lang="en-US" dirty="0"/>
           </a:p>
@@ -893,8 +894,8 @@
             <a:r>
               <a:rPr lang="en-US" dirty="0"/>
               <a:t>PRESENTED BY: 24ada076 - Nuhan (opening)
-We collect three kinds of public data: today's share prices for every listed company, details about individual companies, and company announcements, many of them as PDF files. No logins, and nothing personal.
-But our first attempt found almost nothing - and that's where the story starts.
+We collect three kinds of public data: share prices for every listed company, details for each company, and company announcements, many of them as PDF files. No logins, and nothing personal.
+It all runs in this app, with one tab for each step. But our first attempt found almost nothing - here's why.
 (Hand over to the next speaker.)</a:t>
             </a:r>
             <a:endParaRPr lang="en-US" dirty="0"/>
@@ -984,8 +985,8 @@
             <a:r>
               <a:rPr lang="en-US" dirty="0"/>
               <a:t>(From here, any member can present.)
-We started the way the course taught us, with requests and BeautifulSoup. The trade summary page gave us just 24 characters of text and no tables.
-CSE builds its pages with JavaScript, and requests never runs it. Selenium, a real browser, did see the table - but it took over five seconds for one page.</a:t>
+We started as the course taught us, with requests and BeautifulSoup. The trade summary page gave just 24 characters of text and no tables.
+CSE builds its pages with JavaScript, and requests never runs it. Selenium, a real browser, did see the table - but took over five seconds a page.</a:t>
             </a:r>
             <a:endParaRPr lang="en-US" dirty="0"/>
           </a:p>
@@ -1073,8 +1074,8 @@
           <a:p>
             <a:r>
               <a:rPr lang="en-US" dirty="0"/>
-              <a:t>So we pressed F12 and watched the Network tab. The page fetches its prices from addresses like api/tradeSummary, which answer in JSON.
-We ask those addresses directly - most of them only answer POST requests - and pandas turns the JSON into a table. One request gives us all 284 companies.</a:t>
+              <a:t>We pressed F12 and watched the Network tab. The page gets its prices from addresses like api/tradeSummary, which answer in JSON.
+We ask those addresses directly - most only answer POST - and pandas turns the JSON into a table. One request gives all 284 companies; company details come one at a time, by symbol.</a:t>
             </a:r>
             <a:endParaRPr lang="en-US" dirty="0"/>
           </a:p>
@@ -1162,8 +1163,8 @@
           <a:p>
             <a:r>
               <a:rPr lang="en-US" dirty="0"/>
-              <a:t>Ethical scraping is a main part of the marks, so every request goes through one function.
-It checks robots.txt - CSE only blocks cgi-bin, which we never use. It waits 1.5 seconds, even though CSE doesn't ask us to. It says who we are, logs every request, and keeps a copy so we never ask twice.</a:t>
+              <a:t>Ethics is a main part of the marks, so every request goes through one function.
+It checks robots.txt - CSE only blocks cgi-bin, which we never use. It waits 1.5 seconds, though CSE doesn't ask us to, says who we are, logs every request, and keeps a copy so we never ask twice.</a:t>
             </a:r>
             <a:endParaRPr lang="en-US" dirty="0"/>
           </a:p>
@@ -1251,8 +1252,8 @@
           <a:p>
             <a:r>
               <a:rPr lang="en-US" dirty="0"/>
-              <a:t>For announcements, our crawler reads the list of circulars, finds each PDF on CSE's file server, and downloads a few at a time - skipping copies, and checking each one really is a PDF.
-pdfplumber reads most of them. But one was a scan - a photo of a page, with no text inside.</a:t>
+              <a:t>Our crawler reads the list of circulars, finds each PDF on CSE's file server, and downloads a few at a time, skipping copies. A Scrapy spider does the same crawl, also obeying robots.txt.
+pdfplumber reads the text, PyPDF2 the file details - but one PDF was a scan, with no text inside.</a:t>
             </a:r>
             <a:endParaRPr lang="en-US" dirty="0"/>
           </a:p>
@@ -1340,8 +1341,8 @@
           <a:p>
             <a:r>
               <a:rPr lang="en-US" dirty="0"/>
-              <a:t>For scans we use OCR, in the four steps from the lecture. pdfplumber makes an image. OpenCV turns it grey, then pure black and white - you can see the difference here. pytesseract reads the letters, and pandas tidies the result.
-Every word gets a confidence score, so we know which words to check by hand.</a:t>
+              <a:t>For scans we use OCR, in the lecture's four steps. pdfplumber makes an image, OpenCV turns it grey and then pure black and white - you can see the difference here - pytesseract reads the letters, and pandas tidies the result.
+Every word gets a confidence score, so we know which to check by hand.</a:t>
             </a:r>
             <a:endParaRPr lang="en-US" dirty="0"/>
           </a:p>
@@ -1430,7 +1431,7 @@
             <a:r>
               <a:rPr lang="en-US" dirty="0"/>
               <a:t>Website data is never ready to use. We turn dates from huge numbers into Sri Lanka time, and check the values make sense - all six checks passed.
-On this day, 96 companies rose, 113 fell and 75 didn't move. We save CSV, Excel and JSON, crediting the Colombo Stock Exchange in every file.</a:t>
+The app draws three charts - movers, turnover and sectors. On this day 96 companies rose, 113 fell and 75 didn't move. We save CSV, Excel and JSON, crediting CSE in every file.</a:t>
             </a:r>
             <a:endParaRPr lang="en-US" dirty="0"/>
           </a:p>
@@ -1518,8 +1519,8 @@
           <a:p>
             <a:r>
               <a:rPr lang="en-US" dirty="0"/>
-              <a:t>This is who built each part. Every tab in the app is labelled with its member, and we put the app together as a team.
-Thank you. We're happy to take your questions, and we can show any part of it running in the app.</a:t>
+              <a:t>That's who built each part - every tab in the app is labelled with its member, and we built the app together.
+Thank you. We're happy to take questions, and we can show any part of it running in the app.</a:t>
             </a:r>
             <a:endParaRPr lang="en-US" dirty="0"/>
           </a:p>
@@ -2762,12 +2763,438 @@
         </p:nvSpPr>
         <p:spPr>
           <a:xfrm>
-            <a:off x="548640" y="1874520"/>
-            <a:ext cx="3520440" cy="2743200"/>
+            <a:off x="548640" y="1828800"/>
+            <a:ext cx="548640" cy="548640"/>
+          </a:xfrm>
+          <a:prstGeom prst="ellipse">
+            <a:avLst/>
+          </a:prstGeom>
+          <a:solidFill>
+            <a:srgbClr val="0891B2"/>
+          </a:solidFill>
+          <a:ln w="12700">
+            <a:solidFill>
+              <a:srgbClr val="0891B2"/>
+            </a:solidFill>
+            <a:prstDash val="solid"/>
+          </a:ln>
+        </p:spPr>
+      </p:sp>
+      <p:sp>
+        <p:nvSpPr>
+          <p:cNvPr id="5" name="Text 3"/>
+          <p:cNvSpPr txBox="1"/>
+          <p:nvPr/>
+        </p:nvSpPr>
+        <p:spPr>
+          <a:xfrm>
+            <a:off x="548640" y="1828800"/>
+            <a:ext cx="548640" cy="548640"/>
+          </a:xfrm>
+          <a:prstGeom prst="rect">
+            <a:avLst/>
+          </a:prstGeom>
+          <a:noFill/>
+          <a:ln/>
+        </p:spPr>
+        <p:txBody>
+          <a:bodyPr wrap="square" lIns="0" tIns="0" rIns="0" bIns="0" rtlCol="0" anchor="ctr"/>
+          <a:lstStyle/>
+          <a:p>
+            <a:pPr algn="ctr" indent="0" marL="0">
+              <a:buNone/>
+            </a:pPr>
+            <a:r>
+              <a:rPr lang="en-US" sz="1600" b="1" dirty="0">
+                <a:solidFill>
+                  <a:srgbClr val="FFFFFF"/>
+                </a:solidFill>
+                <a:latin typeface="Calibri" pitchFamily="34" charset="0"/>
+                <a:ea typeface="Calibri" pitchFamily="34" charset="-122"/>
+                <a:cs typeface="Calibri" pitchFamily="34" charset="-120"/>
+              </a:rPr>
+              <a:t>1</a:t>
+            </a:r>
+            <a:endParaRPr lang="en-US" sz="1600" dirty="0"/>
+          </a:p>
+        </p:txBody>
+      </p:sp>
+      <p:sp>
+        <p:nvSpPr>
+          <p:cNvPr id="6" name="Text 4"/>
+          <p:cNvSpPr txBox="1"/>
+          <p:nvPr/>
+        </p:nvSpPr>
+        <p:spPr>
+          <a:xfrm>
+            <a:off x="1325880" y="1810512"/>
+            <a:ext cx="4526280" cy="384048"/>
+          </a:xfrm>
+          <a:prstGeom prst="rect">
+            <a:avLst/>
+          </a:prstGeom>
+          <a:noFill/>
+          <a:ln/>
+        </p:spPr>
+        <p:txBody>
+          <a:bodyPr wrap="square" lIns="0" tIns="0" rIns="0" bIns="0" rtlCol="0" anchor="t"/>
+          <a:lstStyle/>
+          <a:p>
+            <a:pPr indent="0" marL="0">
+              <a:buNone/>
+            </a:pPr>
+            <a:r>
+              <a:rPr lang="en-US" sz="2000" b="1" dirty="0">
+                <a:solidFill>
+                  <a:srgbClr val="161B22"/>
+                </a:solidFill>
+                <a:latin typeface="Calibri" pitchFamily="34" charset="0"/>
+                <a:ea typeface="Calibri" pitchFamily="34" charset="-122"/>
+                <a:cs typeface="Calibri" pitchFamily="34" charset="-120"/>
+              </a:rPr>
+              <a:t>Share prices</a:t>
+            </a:r>
+            <a:endParaRPr lang="en-US" sz="2000" dirty="0"/>
+          </a:p>
+        </p:txBody>
+      </p:sp>
+      <p:sp>
+        <p:nvSpPr>
+          <p:cNvPr id="7" name="Text 5"/>
+          <p:cNvSpPr txBox="1"/>
+          <p:nvPr/>
+        </p:nvSpPr>
+        <p:spPr>
+          <a:xfrm>
+            <a:off x="1325880" y="2194560"/>
+            <a:ext cx="4526280" cy="822960"/>
+          </a:xfrm>
+          <a:prstGeom prst="rect">
+            <a:avLst/>
+          </a:prstGeom>
+          <a:noFill/>
+          <a:ln/>
+        </p:spPr>
+        <p:txBody>
+          <a:bodyPr wrap="square" lIns="0" tIns="0" rIns="0" bIns="0" rtlCol="0" anchor="t"/>
+          <a:lstStyle/>
+          <a:p>
+            <a:pPr indent="0" marL="0">
+              <a:buNone/>
+            </a:pPr>
+            <a:r>
+              <a:rPr lang="en-US" sz="1500" dirty="0">
+                <a:solidFill>
+                  <a:srgbClr val="57606A"/>
+                </a:solidFill>
+                <a:latin typeface="Calibri" pitchFamily="34" charset="0"/>
+                <a:ea typeface="Calibri" pitchFamily="34" charset="-122"/>
+                <a:cs typeface="Calibri" pitchFamily="34" charset="-120"/>
+              </a:rPr>
+              <a:t>Today's price, change and turnover for every listed company - about 284 of them.</a:t>
+            </a:r>
+            <a:endParaRPr lang="en-US" sz="1500" dirty="0"/>
+          </a:p>
+        </p:txBody>
+      </p:sp>
+      <p:sp>
+        <p:nvSpPr>
+          <p:cNvPr id="8" name="Shape 6"/>
+          <p:cNvSpPr/>
+          <p:nvPr/>
+        </p:nvSpPr>
+        <p:spPr>
+          <a:xfrm>
+            <a:off x="548640" y="3200400"/>
+            <a:ext cx="548640" cy="548640"/>
+          </a:xfrm>
+          <a:prstGeom prst="ellipse">
+            <a:avLst/>
+          </a:prstGeom>
+          <a:solidFill>
+            <a:srgbClr val="0891B2"/>
+          </a:solidFill>
+          <a:ln w="12700">
+            <a:solidFill>
+              <a:srgbClr val="0891B2"/>
+            </a:solidFill>
+            <a:prstDash val="solid"/>
+          </a:ln>
+        </p:spPr>
+      </p:sp>
+      <p:sp>
+        <p:nvSpPr>
+          <p:cNvPr id="9" name="Text 7"/>
+          <p:cNvSpPr txBox="1"/>
+          <p:nvPr/>
+        </p:nvSpPr>
+        <p:spPr>
+          <a:xfrm>
+            <a:off x="548640" y="3200400"/>
+            <a:ext cx="548640" cy="548640"/>
+          </a:xfrm>
+          <a:prstGeom prst="rect">
+            <a:avLst/>
+          </a:prstGeom>
+          <a:noFill/>
+          <a:ln/>
+        </p:spPr>
+        <p:txBody>
+          <a:bodyPr wrap="square" lIns="0" tIns="0" rIns="0" bIns="0" rtlCol="0" anchor="ctr"/>
+          <a:lstStyle/>
+          <a:p>
+            <a:pPr algn="ctr" indent="0" marL="0">
+              <a:buNone/>
+            </a:pPr>
+            <a:r>
+              <a:rPr lang="en-US" sz="1600" b="1" dirty="0">
+                <a:solidFill>
+                  <a:srgbClr val="FFFFFF"/>
+                </a:solidFill>
+                <a:latin typeface="Calibri" pitchFamily="34" charset="0"/>
+                <a:ea typeface="Calibri" pitchFamily="34" charset="-122"/>
+                <a:cs typeface="Calibri" pitchFamily="34" charset="-120"/>
+              </a:rPr>
+              <a:t>2</a:t>
+            </a:r>
+            <a:endParaRPr lang="en-US" sz="1600" dirty="0"/>
+          </a:p>
+        </p:txBody>
+      </p:sp>
+      <p:sp>
+        <p:nvSpPr>
+          <p:cNvPr id="10" name="Text 8"/>
+          <p:cNvSpPr txBox="1"/>
+          <p:nvPr/>
+        </p:nvSpPr>
+        <p:spPr>
+          <a:xfrm>
+            <a:off x="1325880" y="3182112"/>
+            <a:ext cx="4526280" cy="384048"/>
+          </a:xfrm>
+          <a:prstGeom prst="rect">
+            <a:avLst/>
+          </a:prstGeom>
+          <a:noFill/>
+          <a:ln/>
+        </p:spPr>
+        <p:txBody>
+          <a:bodyPr wrap="square" lIns="0" tIns="0" rIns="0" bIns="0" rtlCol="0" anchor="t"/>
+          <a:lstStyle/>
+          <a:p>
+            <a:pPr indent="0" marL="0">
+              <a:buNone/>
+            </a:pPr>
+            <a:r>
+              <a:rPr lang="en-US" sz="2000" b="1" dirty="0">
+                <a:solidFill>
+                  <a:srgbClr val="161B22"/>
+                </a:solidFill>
+                <a:latin typeface="Calibri" pitchFamily="34" charset="0"/>
+                <a:ea typeface="Calibri" pitchFamily="34" charset="-122"/>
+                <a:cs typeface="Calibri" pitchFamily="34" charset="-120"/>
+              </a:rPr>
+              <a:t>Company details</a:t>
+            </a:r>
+            <a:endParaRPr lang="en-US" sz="2000" dirty="0"/>
+          </a:p>
+        </p:txBody>
+      </p:sp>
+      <p:sp>
+        <p:nvSpPr>
+          <p:cNvPr id="11" name="Text 9"/>
+          <p:cNvSpPr txBox="1"/>
+          <p:nvPr/>
+        </p:nvSpPr>
+        <p:spPr>
+          <a:xfrm>
+            <a:off x="1325880" y="3566160"/>
+            <a:ext cx="4526280" cy="822960"/>
+          </a:xfrm>
+          <a:prstGeom prst="rect">
+            <a:avLst/>
+          </a:prstGeom>
+          <a:noFill/>
+          <a:ln/>
+        </p:spPr>
+        <p:txBody>
+          <a:bodyPr wrap="square" lIns="0" tIns="0" rIns="0" bIns="0" rtlCol="0" anchor="t"/>
+          <a:lstStyle/>
+          <a:p>
+            <a:pPr indent="0" marL="0">
+              <a:buNone/>
+            </a:pPr>
+            <a:r>
+              <a:rPr lang="en-US" sz="1500" dirty="0">
+                <a:solidFill>
+                  <a:srgbClr val="57606A"/>
+                </a:solidFill>
+                <a:latin typeface="Calibri" pitchFamily="34" charset="0"/>
+                <a:ea typeface="Calibri" pitchFamily="34" charset="-122"/>
+                <a:cs typeface="Calibri" pitchFamily="34" charset="-120"/>
+              </a:rPr>
+              <a:t>One company at a time: its market value, and its highest and lowest price this year.</a:t>
+            </a:r>
+            <a:endParaRPr lang="en-US" sz="1500" dirty="0"/>
+          </a:p>
+        </p:txBody>
+      </p:sp>
+      <p:sp>
+        <p:nvSpPr>
+          <p:cNvPr id="12" name="Shape 10"/>
+          <p:cNvSpPr/>
+          <p:nvPr/>
+        </p:nvSpPr>
+        <p:spPr>
+          <a:xfrm>
+            <a:off x="548640" y="4572000"/>
+            <a:ext cx="548640" cy="548640"/>
+          </a:xfrm>
+          <a:prstGeom prst="ellipse">
+            <a:avLst/>
+          </a:prstGeom>
+          <a:solidFill>
+            <a:srgbClr val="0891B2"/>
+          </a:solidFill>
+          <a:ln w="12700">
+            <a:solidFill>
+              <a:srgbClr val="0891B2"/>
+            </a:solidFill>
+            <a:prstDash val="solid"/>
+          </a:ln>
+        </p:spPr>
+      </p:sp>
+      <p:sp>
+        <p:nvSpPr>
+          <p:cNvPr id="13" name="Text 11"/>
+          <p:cNvSpPr txBox="1"/>
+          <p:nvPr/>
+        </p:nvSpPr>
+        <p:spPr>
+          <a:xfrm>
+            <a:off x="548640" y="4572000"/>
+            <a:ext cx="548640" cy="548640"/>
+          </a:xfrm>
+          <a:prstGeom prst="rect">
+            <a:avLst/>
+          </a:prstGeom>
+          <a:noFill/>
+          <a:ln/>
+        </p:spPr>
+        <p:txBody>
+          <a:bodyPr wrap="square" lIns="0" tIns="0" rIns="0" bIns="0" rtlCol="0" anchor="ctr"/>
+          <a:lstStyle/>
+          <a:p>
+            <a:pPr algn="ctr" indent="0" marL="0">
+              <a:buNone/>
+            </a:pPr>
+            <a:r>
+              <a:rPr lang="en-US" sz="1600" b="1" dirty="0">
+                <a:solidFill>
+                  <a:srgbClr val="FFFFFF"/>
+                </a:solidFill>
+                <a:latin typeface="Calibri" pitchFamily="34" charset="0"/>
+                <a:ea typeface="Calibri" pitchFamily="34" charset="-122"/>
+                <a:cs typeface="Calibri" pitchFamily="34" charset="-120"/>
+              </a:rPr>
+              <a:t>3</a:t>
+            </a:r>
+            <a:endParaRPr lang="en-US" sz="1600" dirty="0"/>
+          </a:p>
+        </p:txBody>
+      </p:sp>
+      <p:sp>
+        <p:nvSpPr>
+          <p:cNvPr id="14" name="Text 12"/>
+          <p:cNvSpPr txBox="1"/>
+          <p:nvPr/>
+        </p:nvSpPr>
+        <p:spPr>
+          <a:xfrm>
+            <a:off x="1325880" y="4553712"/>
+            <a:ext cx="4526280" cy="384048"/>
+          </a:xfrm>
+          <a:prstGeom prst="rect">
+            <a:avLst/>
+          </a:prstGeom>
+          <a:noFill/>
+          <a:ln/>
+        </p:spPr>
+        <p:txBody>
+          <a:bodyPr wrap="square" lIns="0" tIns="0" rIns="0" bIns="0" rtlCol="0" anchor="t"/>
+          <a:lstStyle/>
+          <a:p>
+            <a:pPr indent="0" marL="0">
+              <a:buNone/>
+            </a:pPr>
+            <a:r>
+              <a:rPr lang="en-US" sz="2000" b="1" dirty="0">
+                <a:solidFill>
+                  <a:srgbClr val="161B22"/>
+                </a:solidFill>
+                <a:latin typeface="Calibri" pitchFamily="34" charset="0"/>
+                <a:ea typeface="Calibri" pitchFamily="34" charset="-122"/>
+                <a:cs typeface="Calibri" pitchFamily="34" charset="-120"/>
+              </a:rPr>
+              <a:t>Announcements</a:t>
+            </a:r>
+            <a:endParaRPr lang="en-US" sz="2000" dirty="0"/>
+          </a:p>
+        </p:txBody>
+      </p:sp>
+      <p:sp>
+        <p:nvSpPr>
+          <p:cNvPr id="15" name="Text 13"/>
+          <p:cNvSpPr txBox="1"/>
+          <p:nvPr/>
+        </p:nvSpPr>
+        <p:spPr>
+          <a:xfrm>
+            <a:off x="1325880" y="4937760"/>
+            <a:ext cx="4526280" cy="822960"/>
+          </a:xfrm>
+          <a:prstGeom prst="rect">
+            <a:avLst/>
+          </a:prstGeom>
+          <a:noFill/>
+          <a:ln/>
+        </p:spPr>
+        <p:txBody>
+          <a:bodyPr wrap="square" lIns="0" tIns="0" rIns="0" bIns="0" rtlCol="0" anchor="t"/>
+          <a:lstStyle/>
+          <a:p>
+            <a:pPr indent="0" marL="0">
+              <a:buNone/>
+            </a:pPr>
+            <a:r>
+              <a:rPr lang="en-US" sz="1500" dirty="0">
+                <a:solidFill>
+                  <a:srgbClr val="57606A"/>
+                </a:solidFill>
+                <a:latin typeface="Calibri" pitchFamily="34" charset="0"/>
+                <a:ea typeface="Calibri" pitchFamily="34" charset="-122"/>
+                <a:cs typeface="Calibri" pitchFamily="34" charset="-120"/>
+              </a:rPr>
+              <a:t>Notices companies publish - many as PDF files, and some of those are scans.</a:t>
+            </a:r>
+            <a:endParaRPr lang="en-US" sz="1500" dirty="0"/>
+          </a:p>
+        </p:txBody>
+      </p:sp>
+      <p:sp>
+        <p:nvSpPr>
+          <p:cNvPr id="16" name="Shape 14"/>
+          <p:cNvSpPr/>
+          <p:nvPr/>
+        </p:nvSpPr>
+        <p:spPr>
+          <a:xfrm>
+            <a:off x="5852160" y="1691640"/>
+            <a:ext cx="5928055" cy="3582362"/>
           </a:xfrm>
           <a:prstGeom prst="roundRect">
             <a:avLst>
-              <a:gd name="adj" fmla="val 4000"/>
+              <a:gd name="adj" fmla="val 3063"/>
             </a:avLst>
           </a:prstGeom>
           <a:solidFill>
@@ -2781,26 +3208,47 @@
           </a:ln>
         </p:spPr>
       </p:sp>
-      <p:sp>
-        <p:nvSpPr>
-          <p:cNvPr id="5" name="Shape 3"/>
+      <p:pic>
+        <p:nvPicPr>
+          <p:cNvPr id="17" name="Image 0" descr="D:/DA2009/CSE-Scraping-Project/guide_content/images/app_market.png">    </p:cNvPr>
+          <p:cNvPicPr>
+            <a:picLocks noChangeAspect="1"/>
+          </p:cNvPicPr>
+          <p:nvPr/>
+        </p:nvPicPr>
+        <p:blipFill>
+          <a:blip r:embed="rId1"/>
+          <a:stretch>
+            <a:fillRect/>
+          </a:stretch>
+        </p:blipFill>
+        <p:spPr>
+          <a:xfrm>
+            <a:off x="5989320" y="1828800"/>
+            <a:ext cx="5653735" cy="2622242"/>
+          </a:xfrm>
+          <a:prstGeom prst="rect">
+            <a:avLst/>
+          </a:prstGeom>
+        </p:spPr>
+      </p:pic>
+      <p:sp>
+        <p:nvSpPr>
+          <p:cNvPr id="18" name="Shape 15"/>
           <p:cNvSpPr/>
           <p:nvPr/>
         </p:nvSpPr>
         <p:spPr>
           <a:xfrm>
-            <a:off x="868680" y="2194560"/>
-            <a:ext cx="640080" cy="640080"/>
-          </a:xfrm>
-          <a:prstGeom prst="ellipse">
-            <a:avLst/>
-          </a:prstGeom>
-          <a:solidFill>
-            <a:srgbClr val="0891B2"/>
-          </a:solidFill>
+            <a:off x="5989320" y="1828800"/>
+            <a:ext cx="5653735" cy="2622242"/>
+          </a:xfrm>
+          <a:prstGeom prst="rect">
+            <a:avLst/>
+          </a:prstGeom>
           <a:ln w="12700">
             <a:solidFill>
-              <a:srgbClr val="0891B2"/>
+              <a:srgbClr val="D0D7DE"/>
             </a:solidFill>
             <a:prstDash val="solid"/>
           </a:ln>
@@ -2808,69 +3256,30 @@
       </p:sp>
       <p:sp>
         <p:nvSpPr>
-          <p:cNvPr id="6" name="Text 4"/>
-          <p:cNvSpPr txBox="1"/>
-          <p:nvPr/>
-        </p:nvSpPr>
-        <p:spPr>
-          <a:xfrm>
-            <a:off x="868680" y="2194560"/>
-            <a:ext cx="640080" cy="640080"/>
-          </a:xfrm>
-          <a:prstGeom prst="rect">
-            <a:avLst/>
-          </a:prstGeom>
-          <a:noFill/>
-          <a:ln/>
-        </p:spPr>
-        <p:txBody>
-          <a:bodyPr wrap="square" lIns="0" tIns="0" rIns="0" bIns="0" rtlCol="0" anchor="ctr"/>
-          <a:lstStyle/>
-          <a:p>
-            <a:pPr algn="ctr" indent="0" marL="0">
-              <a:buNone/>
-            </a:pPr>
-            <a:r>
-              <a:rPr lang="en-US" sz="2200" b="1" dirty="0">
-                <a:solidFill>
-                  <a:srgbClr val="FFFFFF"/>
-                </a:solidFill>
-                <a:latin typeface="Calibri" pitchFamily="34" charset="0"/>
-                <a:ea typeface="Calibri" pitchFamily="34" charset="-122"/>
-                <a:cs typeface="Calibri" pitchFamily="34" charset="-120"/>
-              </a:rPr>
-              <a:t>1</a:t>
-            </a:r>
-            <a:endParaRPr lang="en-US" sz="2200" dirty="0"/>
-          </a:p>
-        </p:txBody>
-      </p:sp>
-      <p:sp>
-        <p:nvSpPr>
-          <p:cNvPr id="7" name="Text 5"/>
-          <p:cNvSpPr txBox="1"/>
-          <p:nvPr/>
-        </p:nvSpPr>
-        <p:spPr>
-          <a:xfrm>
-            <a:off x="868680" y="3017520"/>
-            <a:ext cx="2880360" cy="457200"/>
-          </a:xfrm>
-          <a:prstGeom prst="rect">
-            <a:avLst/>
-          </a:prstGeom>
-          <a:noFill/>
-          <a:ln/>
-        </p:spPr>
-        <p:txBody>
-          <a:bodyPr wrap="square" lIns="0" tIns="0" rIns="0" bIns="0" rtlCol="0" anchor="t"/>
-          <a:lstStyle/>
-          <a:p>
-            <a:pPr indent="0" marL="0">
-              <a:buNone/>
-            </a:pPr>
-            <a:r>
-              <a:rPr lang="en-US" sz="2200" b="1" dirty="0">
+          <p:cNvPr id="19" name="Text 16"/>
+          <p:cNvSpPr txBox="1"/>
+          <p:nvPr/>
+        </p:nvSpPr>
+        <p:spPr>
+          <a:xfrm>
+            <a:off x="5989320" y="4588202"/>
+            <a:ext cx="5653735" cy="640080"/>
+          </a:xfrm>
+          <a:prstGeom prst="rect">
+            <a:avLst/>
+          </a:prstGeom>
+          <a:noFill/>
+          <a:ln/>
+        </p:spPr>
+        <p:txBody>
+          <a:bodyPr wrap="square" lIns="0" tIns="0" rIns="0" bIns="0" rtlCol="0" anchor="t"/>
+          <a:lstStyle/>
+          <a:p>
+            <a:pPr indent="0" marL="0">
+              <a:buNone/>
+            </a:pPr>
+            <a:r>
+              <a:rPr lang="en-US" sz="1500" b="1" dirty="0">
                 <a:solidFill>
                   <a:srgbClr val="161B22"/>
                 </a:solidFill>
@@ -2878,38 +3287,13 @@
                 <a:ea typeface="Calibri" pitchFamily="34" charset="-122"/>
                 <a:cs typeface="Calibri" pitchFamily="34" charset="-120"/>
               </a:rPr>
-              <a:t>Share prices</a:t>
-            </a:r>
-            <a:endParaRPr lang="en-US" sz="2200" dirty="0"/>
-          </a:p>
-        </p:txBody>
-      </p:sp>
-      <p:sp>
-        <p:nvSpPr>
-          <p:cNvPr id="8" name="Text 6"/>
-          <p:cNvSpPr txBox="1"/>
-          <p:nvPr/>
-        </p:nvSpPr>
-        <p:spPr>
-          <a:xfrm>
-            <a:off x="868680" y="3520440"/>
-            <a:ext cx="2880360" cy="1005840"/>
-          </a:xfrm>
-          <a:prstGeom prst="rect">
-            <a:avLst/>
-          </a:prstGeom>
-          <a:noFill/>
-          <a:ln/>
-        </p:spPr>
-        <p:txBody>
-          <a:bodyPr wrap="square" lIns="0" tIns="0" rIns="0" bIns="0" rtlCol="0" anchor="t"/>
-          <a:lstStyle/>
-          <a:p>
-            <a:pPr indent="0" marL="0">
-              <a:buNone/>
-            </a:pPr>
-            <a:r>
-              <a:rPr lang="en-US" sz="1600" dirty="0">
+              <a:t>Our app</a:t>
+            </a:r>
+            <a:pPr indent="0" marL="0">
+              <a:buNone/>
+            </a:pPr>
+            <a:r>
+              <a:rPr lang="en-US" sz="1500" dirty="0">
                 <a:solidFill>
                   <a:srgbClr val="57606A"/>
                 </a:solidFill>
@@ -2917,433 +3301,15 @@
                 <a:ea typeface="Calibri" pitchFamily="34" charset="-122"/>
                 <a:cs typeface="Calibri" pitchFamily="34" charset="-120"/>
               </a:rPr>
-              <a:t>Today's price, change and turnover for every listed company - about 284 of them.</a:t>
-            </a:r>
-            <a:endParaRPr lang="en-US" sz="1600" dirty="0"/>
-          </a:p>
-        </p:txBody>
-      </p:sp>
-      <p:sp>
-        <p:nvSpPr>
-          <p:cNvPr id="9" name="Shape 7"/>
-          <p:cNvSpPr/>
-          <p:nvPr/>
-        </p:nvSpPr>
-        <p:spPr>
-          <a:xfrm>
-            <a:off x="4325112" y="1874520"/>
-            <a:ext cx="3520440" cy="2743200"/>
-          </a:xfrm>
-          <a:prstGeom prst="roundRect">
-            <a:avLst>
-              <a:gd name="adj" fmla="val 4000"/>
-            </a:avLst>
-          </a:prstGeom>
-          <a:solidFill>
-            <a:srgbClr val="F1F5F9"/>
-          </a:solidFill>
-          <a:ln w="12700">
-            <a:solidFill>
-              <a:srgbClr val="F1F5F9"/>
-            </a:solidFill>
-            <a:prstDash val="solid"/>
-          </a:ln>
-        </p:spPr>
-      </p:sp>
-      <p:sp>
-        <p:nvSpPr>
-          <p:cNvPr id="10" name="Shape 8"/>
-          <p:cNvSpPr/>
-          <p:nvPr/>
-        </p:nvSpPr>
-        <p:spPr>
-          <a:xfrm>
-            <a:off x="4645152" y="2194560"/>
-            <a:ext cx="640080" cy="640080"/>
-          </a:xfrm>
-          <a:prstGeom prst="ellipse">
-            <a:avLst/>
-          </a:prstGeom>
-          <a:solidFill>
-            <a:srgbClr val="0891B2"/>
-          </a:solidFill>
-          <a:ln w="12700">
-            <a:solidFill>
-              <a:srgbClr val="0891B2"/>
-            </a:solidFill>
-            <a:prstDash val="solid"/>
-          </a:ln>
-        </p:spPr>
-      </p:sp>
-      <p:sp>
-        <p:nvSpPr>
-          <p:cNvPr id="11" name="Text 9"/>
-          <p:cNvSpPr txBox="1"/>
-          <p:nvPr/>
-        </p:nvSpPr>
-        <p:spPr>
-          <a:xfrm>
-            <a:off x="4645152" y="2194560"/>
-            <a:ext cx="640080" cy="640080"/>
-          </a:xfrm>
-          <a:prstGeom prst="rect">
-            <a:avLst/>
-          </a:prstGeom>
-          <a:noFill/>
-          <a:ln/>
-        </p:spPr>
-        <p:txBody>
-          <a:bodyPr wrap="square" lIns="0" tIns="0" rIns="0" bIns="0" rtlCol="0" anchor="ctr"/>
-          <a:lstStyle/>
-          <a:p>
-            <a:pPr algn="ctr" indent="0" marL="0">
-              <a:buNone/>
-            </a:pPr>
-            <a:r>
-              <a:rPr lang="en-US" sz="2200" b="1" dirty="0">
-                <a:solidFill>
-                  <a:srgbClr val="FFFFFF"/>
-                </a:solidFill>
-                <a:latin typeface="Calibri" pitchFamily="34" charset="0"/>
-                <a:ea typeface="Calibri" pitchFamily="34" charset="-122"/>
-                <a:cs typeface="Calibri" pitchFamily="34" charset="-120"/>
-              </a:rPr>
-              <a:t>2</a:t>
-            </a:r>
-            <a:endParaRPr lang="en-US" sz="2200" dirty="0"/>
-          </a:p>
-        </p:txBody>
-      </p:sp>
-      <p:sp>
-        <p:nvSpPr>
-          <p:cNvPr id="12" name="Text 10"/>
-          <p:cNvSpPr txBox="1"/>
-          <p:nvPr/>
-        </p:nvSpPr>
-        <p:spPr>
-          <a:xfrm>
-            <a:off x="4645152" y="3017520"/>
-            <a:ext cx="2880360" cy="457200"/>
-          </a:xfrm>
-          <a:prstGeom prst="rect">
-            <a:avLst/>
-          </a:prstGeom>
-          <a:noFill/>
-          <a:ln/>
-        </p:spPr>
-        <p:txBody>
-          <a:bodyPr wrap="square" lIns="0" tIns="0" rIns="0" bIns="0" rtlCol="0" anchor="t"/>
-          <a:lstStyle/>
-          <a:p>
-            <a:pPr indent="0" marL="0">
-              <a:buNone/>
-            </a:pPr>
-            <a:r>
-              <a:rPr lang="en-US" sz="2200" b="1" dirty="0">
-                <a:solidFill>
-                  <a:srgbClr val="161B22"/>
-                </a:solidFill>
-                <a:latin typeface="Calibri" pitchFamily="34" charset="0"/>
-                <a:ea typeface="Calibri" pitchFamily="34" charset="-122"/>
-                <a:cs typeface="Calibri" pitchFamily="34" charset="-120"/>
-              </a:rPr>
-              <a:t>Company details</a:t>
-            </a:r>
-            <a:endParaRPr lang="en-US" sz="2200" dirty="0"/>
-          </a:p>
-        </p:txBody>
-      </p:sp>
-      <p:sp>
-        <p:nvSpPr>
-          <p:cNvPr id="13" name="Text 11"/>
-          <p:cNvSpPr txBox="1"/>
-          <p:nvPr/>
-        </p:nvSpPr>
-        <p:spPr>
-          <a:xfrm>
-            <a:off x="4645152" y="3520440"/>
-            <a:ext cx="2880360" cy="1005840"/>
-          </a:xfrm>
-          <a:prstGeom prst="rect">
-            <a:avLst/>
-          </a:prstGeom>
-          <a:noFill/>
-          <a:ln/>
-        </p:spPr>
-        <p:txBody>
-          <a:bodyPr wrap="square" lIns="0" tIns="0" rIns="0" bIns="0" rtlCol="0" anchor="t"/>
-          <a:lstStyle/>
-          <a:p>
-            <a:pPr indent="0" marL="0">
-              <a:buNone/>
-            </a:pPr>
-            <a:r>
-              <a:rPr lang="en-US" sz="1600" dirty="0">
-                <a:solidFill>
-                  <a:srgbClr val="57606A"/>
-                </a:solidFill>
-                <a:latin typeface="Calibri" pitchFamily="34" charset="0"/>
-                <a:ea typeface="Calibri" pitchFamily="34" charset="-122"/>
-                <a:cs typeface="Calibri" pitchFamily="34" charset="-120"/>
-              </a:rPr>
-              <a:t>Facts about one company: its market value, and its highest and lowest price this year.</a:t>
-            </a:r>
-            <a:endParaRPr lang="en-US" sz="1600" dirty="0"/>
-          </a:p>
-        </p:txBody>
-      </p:sp>
-      <p:sp>
-        <p:nvSpPr>
-          <p:cNvPr id="14" name="Shape 12"/>
-          <p:cNvSpPr/>
-          <p:nvPr/>
-        </p:nvSpPr>
-        <p:spPr>
-          <a:xfrm>
-            <a:off x="8101584" y="1874520"/>
-            <a:ext cx="3520440" cy="2743200"/>
-          </a:xfrm>
-          <a:prstGeom prst="roundRect">
-            <a:avLst>
-              <a:gd name="adj" fmla="val 4000"/>
-            </a:avLst>
-          </a:prstGeom>
-          <a:solidFill>
-            <a:srgbClr val="F1F5F9"/>
-          </a:solidFill>
-          <a:ln w="12700">
-            <a:solidFill>
-              <a:srgbClr val="F1F5F9"/>
-            </a:solidFill>
-            <a:prstDash val="solid"/>
-          </a:ln>
-        </p:spPr>
-      </p:sp>
-      <p:sp>
-        <p:nvSpPr>
-          <p:cNvPr id="15" name="Shape 13"/>
-          <p:cNvSpPr/>
-          <p:nvPr/>
-        </p:nvSpPr>
-        <p:spPr>
-          <a:xfrm>
-            <a:off x="8421624" y="2194560"/>
-            <a:ext cx="640080" cy="640080"/>
-          </a:xfrm>
-          <a:prstGeom prst="ellipse">
-            <a:avLst/>
-          </a:prstGeom>
-          <a:solidFill>
-            <a:srgbClr val="0891B2"/>
-          </a:solidFill>
-          <a:ln w="12700">
-            <a:solidFill>
-              <a:srgbClr val="0891B2"/>
-            </a:solidFill>
-            <a:prstDash val="solid"/>
-          </a:ln>
-        </p:spPr>
-      </p:sp>
-      <p:sp>
-        <p:nvSpPr>
-          <p:cNvPr id="16" name="Text 14"/>
-          <p:cNvSpPr txBox="1"/>
-          <p:nvPr/>
-        </p:nvSpPr>
-        <p:spPr>
-          <a:xfrm>
-            <a:off x="8421624" y="2194560"/>
-            <a:ext cx="640080" cy="640080"/>
-          </a:xfrm>
-          <a:prstGeom prst="rect">
-            <a:avLst/>
-          </a:prstGeom>
-          <a:noFill/>
-          <a:ln/>
-        </p:spPr>
-        <p:txBody>
-          <a:bodyPr wrap="square" lIns="0" tIns="0" rIns="0" bIns="0" rtlCol="0" anchor="ctr"/>
-          <a:lstStyle/>
-          <a:p>
-            <a:pPr algn="ctr" indent="0" marL="0">
-              <a:buNone/>
-            </a:pPr>
-            <a:r>
-              <a:rPr lang="en-US" sz="2200" b="1" dirty="0">
-                <a:solidFill>
-                  <a:srgbClr val="FFFFFF"/>
-                </a:solidFill>
-                <a:latin typeface="Calibri" pitchFamily="34" charset="0"/>
-                <a:ea typeface="Calibri" pitchFamily="34" charset="-122"/>
-                <a:cs typeface="Calibri" pitchFamily="34" charset="-120"/>
-              </a:rPr>
-              <a:t>3</a:t>
-            </a:r>
-            <a:endParaRPr lang="en-US" sz="2200" dirty="0"/>
-          </a:p>
-        </p:txBody>
-      </p:sp>
-      <p:sp>
-        <p:nvSpPr>
-          <p:cNvPr id="17" name="Text 15"/>
-          <p:cNvSpPr txBox="1"/>
-          <p:nvPr/>
-        </p:nvSpPr>
-        <p:spPr>
-          <a:xfrm>
-            <a:off x="8421624" y="3017520"/>
-            <a:ext cx="2880360" cy="457200"/>
-          </a:xfrm>
-          <a:prstGeom prst="rect">
-            <a:avLst/>
-          </a:prstGeom>
-          <a:noFill/>
-          <a:ln/>
-        </p:spPr>
-        <p:txBody>
-          <a:bodyPr wrap="square" lIns="0" tIns="0" rIns="0" bIns="0" rtlCol="0" anchor="t"/>
-          <a:lstStyle/>
-          <a:p>
-            <a:pPr indent="0" marL="0">
-              <a:buNone/>
-            </a:pPr>
-            <a:r>
-              <a:rPr lang="en-US" sz="2200" b="1" dirty="0">
-                <a:solidFill>
-                  <a:srgbClr val="161B22"/>
-                </a:solidFill>
-                <a:latin typeface="Calibri" pitchFamily="34" charset="0"/>
-                <a:ea typeface="Calibri" pitchFamily="34" charset="-122"/>
-                <a:cs typeface="Calibri" pitchFamily="34" charset="-120"/>
-              </a:rPr>
-              <a:t>Announcements</a:t>
-            </a:r>
-            <a:endParaRPr lang="en-US" sz="2200" dirty="0"/>
-          </a:p>
-        </p:txBody>
-      </p:sp>
-      <p:sp>
-        <p:nvSpPr>
-          <p:cNvPr id="18" name="Text 16"/>
-          <p:cNvSpPr txBox="1"/>
-          <p:nvPr/>
-        </p:nvSpPr>
-        <p:spPr>
-          <a:xfrm>
-            <a:off x="8421624" y="3520440"/>
-            <a:ext cx="2880360" cy="1005840"/>
-          </a:xfrm>
-          <a:prstGeom prst="rect">
-            <a:avLst/>
-          </a:prstGeom>
-          <a:noFill/>
-          <a:ln/>
-        </p:spPr>
-        <p:txBody>
-          <a:bodyPr wrap="square" lIns="0" tIns="0" rIns="0" bIns="0" rtlCol="0" anchor="t"/>
-          <a:lstStyle/>
-          <a:p>
-            <a:pPr indent="0" marL="0">
-              <a:buNone/>
-            </a:pPr>
-            <a:r>
-              <a:rPr lang="en-US" sz="1600" dirty="0">
-                <a:solidFill>
-                  <a:srgbClr val="57606A"/>
-                </a:solidFill>
-                <a:latin typeface="Calibri" pitchFamily="34" charset="0"/>
-                <a:ea typeface="Calibri" pitchFamily="34" charset="-122"/>
-                <a:cs typeface="Calibri" pitchFamily="34" charset="-120"/>
-              </a:rPr>
-              <a:t>Notices companies publish - many of them as PDF files, and some of those are scans.</a:t>
-            </a:r>
-            <a:endParaRPr lang="en-US" sz="1600" dirty="0"/>
-          </a:p>
-        </p:txBody>
-      </p:sp>
-      <p:sp>
-        <p:nvSpPr>
-          <p:cNvPr id="19" name="Shape 17"/>
-          <p:cNvSpPr/>
-          <p:nvPr/>
-        </p:nvSpPr>
-        <p:spPr>
-          <a:xfrm>
-            <a:off x="548640" y="4983480"/>
-            <a:ext cx="11094415" cy="1051560"/>
-          </a:xfrm>
-          <a:prstGeom prst="roundRect">
-            <a:avLst>
-              <a:gd name="adj" fmla="val 10435"/>
-            </a:avLst>
-          </a:prstGeom>
-          <a:solidFill>
-            <a:srgbClr val="E0F2F7"/>
-          </a:solidFill>
-          <a:ln w="12700">
-            <a:solidFill>
-              <a:srgbClr val="E0F2F7"/>
-            </a:solidFill>
-            <a:prstDash val="solid"/>
-          </a:ln>
-        </p:spPr>
-      </p:sp>
-      <p:sp>
-        <p:nvSpPr>
-          <p:cNvPr id="20" name="Text 18"/>
-          <p:cNvSpPr txBox="1"/>
-          <p:nvPr/>
-        </p:nvSpPr>
-        <p:spPr>
-          <a:xfrm>
-            <a:off x="868680" y="4983480"/>
-            <a:ext cx="10454335" cy="1051560"/>
-          </a:xfrm>
-          <a:prstGeom prst="rect">
-            <a:avLst/>
-          </a:prstGeom>
-          <a:noFill/>
-          <a:ln/>
-        </p:spPr>
-        <p:txBody>
-          <a:bodyPr wrap="square" lIns="0" tIns="0" rIns="0" bIns="0" rtlCol="0" anchor="ctr"/>
-          <a:lstStyle/>
-          <a:p>
-            <a:pPr indent="0" marL="0">
-              <a:buNone/>
-            </a:pPr>
-            <a:r>
-              <a:rPr lang="en-US" sz="1800" b="1" dirty="0">
-                <a:solidFill>
-                  <a:srgbClr val="161B22"/>
-                </a:solidFill>
-                <a:latin typeface="Calibri" pitchFamily="34" charset="0"/>
-                <a:ea typeface="Calibri" pitchFamily="34" charset="-122"/>
-                <a:cs typeface="Calibri" pitchFamily="34" charset="-120"/>
-              </a:rPr>
-              <a:t>Then we clean it, check it, chart it and save it</a:t>
-            </a:r>
-            <a:pPr indent="0" marL="0">
-              <a:buNone/>
-            </a:pPr>
-            <a:r>
-              <a:rPr lang="en-US" sz="1800" dirty="0">
-                <a:solidFill>
-                  <a:srgbClr val="161B22"/>
-                </a:solidFill>
-                <a:latin typeface="Calibri" pitchFamily="34" charset="0"/>
-                <a:ea typeface="Calibri" pitchFamily="34" charset="-122"/>
-                <a:cs typeface="Calibri" pitchFamily="34" charset="-120"/>
-              </a:rPr>
-              <a:t> - in an app with a tab for every step, labelled with the member who built it.</a:t>
-            </a:r>
-            <a:endParaRPr lang="en-US" sz="1800" dirty="0"/>
-          </a:p>
-        </p:txBody>
-      </p:sp>
-      <p:sp>
-        <p:nvSpPr>
-          <p:cNvPr id="21" name="Text 19"/>
+              <a:t> - one tab for each step, each labelled with the member who built it</a:t>
+            </a:r>
+            <a:endParaRPr lang="en-US" sz="1500" dirty="0"/>
+          </a:p>
+        </p:txBody>
+      </p:sp>
+      <p:sp>
+        <p:nvSpPr>
+          <p:cNvPr id="20" name="Text 17"/>
           <p:cNvSpPr txBox="1"/>
           <p:nvPr/>
         </p:nvSpPr>
@@ -4364,7 +4330,7 @@
                 <a:ea typeface="Calibri" pitchFamily="34" charset="-122"/>
                 <a:cs typeface="Calibri" pitchFamily="34" charset="-120"/>
               </a:rPr>
-              <a:t>The page asks /api/tradeSummary for its prices</a:t>
+              <a:t>The page POSTs to /api/tradeSummary for its prices</a:t>
             </a:r>
             <a:endParaRPr lang="en-US" sz="1500" dirty="0"/>
           </a:p>
@@ -4962,7 +4928,7 @@
                 <a:ea typeface="Calibri" pitchFamily="34" charset="-122"/>
                 <a:cs typeface="Calibri" pitchFamily="34" charset="-120"/>
               </a:rPr>
-              <a:t>Most of these addresses only answer POST requests</a:t>
+              <a:t>Company details: one request per company, by symbol</a:t>
             </a:r>
             <a:endParaRPr lang="en-US" sz="1500" dirty="0"/>
           </a:p>
@@ -6720,18 +6686,71 @@
       </p:sp>
       <p:sp>
         <p:nvSpPr>
-          <p:cNvPr id="18" name="Shape 16"/>
+          <p:cNvPr id="18" name="Text 16"/>
+          <p:cNvSpPr txBox="1"/>
+          <p:nvPr/>
+        </p:nvSpPr>
+        <p:spPr>
+          <a:xfrm>
+            <a:off x="548640" y="3520440"/>
+            <a:ext cx="11094415" cy="365760"/>
+          </a:xfrm>
+          <a:prstGeom prst="rect">
+            <a:avLst/>
+          </a:prstGeom>
+          <a:noFill/>
+          <a:ln/>
+        </p:spPr>
+        <p:txBody>
+          <a:bodyPr wrap="square" lIns="0" tIns="0" rIns="0" bIns="0" rtlCol="0" anchor="t"/>
+          <a:lstStyle/>
+          <a:p>
+            <a:pPr indent="0" marL="0">
+              <a:buNone/>
+            </a:pPr>
+            <a:r>
+              <a:rPr lang="en-US" sz="1600" b="1" dirty="0">
+                <a:solidFill>
+                  <a:srgbClr val="0891B2"/>
+                </a:solidFill>
+                <a:latin typeface="Calibri" pitchFamily="34" charset="0"/>
+                <a:ea typeface="Calibri" pitchFamily="34" charset="-122"/>
+                <a:cs typeface="Calibri" pitchFamily="34" charset="-120"/>
+              </a:rPr>
+              <a:t>Done twice: </a:t>
+            </a:r>
+            <a:pPr indent="0" marL="0">
+              <a:buNone/>
+            </a:pPr>
+            <a:r>
+              <a:rPr lang="en-US" sz="1600" dirty="0">
+                <a:solidFill>
+                  <a:srgbClr val="161B22"/>
+                </a:solidFill>
+                <a:latin typeface="Calibri" pitchFamily="34" charset="0"/>
+                <a:ea typeface="Calibri" pitchFamily="34" charset="-122"/>
+                <a:cs typeface="Calibri" pitchFamily="34" charset="-120"/>
+              </a:rPr>
+              <a:t>our own crawler, and a Scrapy spider - robots.txt obeyed, 1.5 seconds between requests</a:t>
+            </a:r>
+            <a:endParaRPr lang="en-US" sz="1600" dirty="0"/>
+          </a:p>
+        </p:txBody>
+      </p:sp>
+      <p:sp>
+        <p:nvSpPr>
+          <p:cNvPr id="19" name="Shape 17"/>
           <p:cNvSpPr/>
           <p:nvPr/>
         </p:nvSpPr>
         <p:spPr>
           <a:xfrm>
-            <a:off x="548640" y="3703320"/>
-            <a:ext cx="3429000" cy="2423160"/>
+            <a:off x="548640" y="4069080"/>
+            <a:ext cx="3429000" cy="2103120"/>
           </a:xfrm>
           <a:prstGeom prst="roundRect">
             <a:avLst>
-              <a:gd name="adj" fmla="val 4528"/>
+              <a:gd name="adj" fmla="val 5217"/>
             </a:avLst>
           </a:prstGeom>
           <a:solidFill>
@@ -6747,13 +6766,13 @@
       </p:sp>
       <p:sp>
         <p:nvSpPr>
-          <p:cNvPr id="19" name="Text 17"/>
-          <p:cNvSpPr txBox="1"/>
-          <p:nvPr/>
-        </p:nvSpPr>
-        <p:spPr>
-          <a:xfrm>
-            <a:off x="822960" y="3886200"/>
+          <p:cNvPr id="20" name="Text 18"/>
+          <p:cNvSpPr txBox="1"/>
+          <p:nvPr/>
+        </p:nvSpPr>
+        <p:spPr>
+          <a:xfrm>
+            <a:off x="822960" y="4233672"/>
             <a:ext cx="2880360" cy="384048"/>
           </a:xfrm>
           <a:prstGeom prst="rect">
@@ -6786,14 +6805,14 @@
       </p:sp>
       <p:sp>
         <p:nvSpPr>
-          <p:cNvPr id="20" name="Text 18"/>
-          <p:cNvSpPr txBox="1"/>
-          <p:nvPr/>
-        </p:nvSpPr>
-        <p:spPr>
-          <a:xfrm>
-            <a:off x="822960" y="4297680"/>
-            <a:ext cx="2880360" cy="777240"/>
+          <p:cNvPr id="21" name="Text 19"/>
+          <p:cNvSpPr txBox="1"/>
+          <p:nvPr/>
+        </p:nvSpPr>
+        <p:spPr>
+          <a:xfrm>
+            <a:off x="822960" y="4617720"/>
+            <a:ext cx="2880360" cy="685800"/>
           </a:xfrm>
           <a:prstGeom prst="rect">
             <a:avLst/>
@@ -6809,7 +6828,7 @@
               <a:buNone/>
             </a:pPr>
             <a:r>
-              <a:rPr lang="en-US" sz="5400" b="1" dirty="0">
+              <a:rPr lang="en-US" sz="5000" b="1" dirty="0">
                 <a:solidFill>
                   <a:srgbClr val="0891B2"/>
                 </a:solidFill>
@@ -6819,20 +6838,20 @@
               </a:rPr>
               <a:t>896</a:t>
             </a:r>
-            <a:endParaRPr lang="en-US" sz="5400" dirty="0"/>
-          </a:p>
-        </p:txBody>
-      </p:sp>
-      <p:sp>
-        <p:nvSpPr>
-          <p:cNvPr id="21" name="Text 19"/>
-          <p:cNvSpPr txBox="1"/>
-          <p:nvPr/>
-        </p:nvSpPr>
-        <p:spPr>
-          <a:xfrm>
-            <a:off x="822960" y="5074920"/>
-            <a:ext cx="2880360" cy="320040"/>
+            <a:endParaRPr lang="en-US" sz="5000" dirty="0"/>
+          </a:p>
+        </p:txBody>
+      </p:sp>
+      <p:sp>
+        <p:nvSpPr>
+          <p:cNvPr id="22" name="Text 20"/>
+          <p:cNvSpPr txBox="1"/>
+          <p:nvPr/>
+        </p:nvSpPr>
+        <p:spPr>
+          <a:xfrm>
+            <a:off x="822960" y="5321808"/>
+            <a:ext cx="2880360" cy="301752"/>
           </a:xfrm>
           <a:prstGeom prst="rect">
             <a:avLst/>
@@ -6864,14 +6883,14 @@
       </p:sp>
       <p:sp>
         <p:nvSpPr>
-          <p:cNvPr id="22" name="Text 20"/>
-          <p:cNvSpPr txBox="1"/>
-          <p:nvPr/>
-        </p:nvSpPr>
-        <p:spPr>
-          <a:xfrm>
-            <a:off x="822960" y="5394960"/>
-            <a:ext cx="2880360" cy="640080"/>
+          <p:cNvPr id="23" name="Text 21"/>
+          <p:cNvSpPr txBox="1"/>
+          <p:nvPr/>
+        </p:nvSpPr>
+        <p:spPr>
+          <a:xfrm>
+            <a:off x="822960" y="5623560"/>
+            <a:ext cx="2880360" cy="502920"/>
           </a:xfrm>
           <a:prstGeom prst="rect">
             <a:avLst/>
@@ -6895,7 +6914,7 @@
                 <a:ea typeface="Calibri" pitchFamily="34" charset="-122"/>
                 <a:cs typeface="Calibri" pitchFamily="34" charset="-120"/>
               </a:rPr>
-              <a:t>pdfplumber reads the text straight out of the file</a:t>
+              <a:t>pdfplumber reads the text; PyPDF2 reads the file details</a:t>
             </a:r>
             <a:endParaRPr lang="en-US" sz="1400" dirty="0"/>
           </a:p>
@@ -6903,18 +6922,18 @@
       </p:sp>
       <p:sp>
         <p:nvSpPr>
-          <p:cNvPr id="23" name="Shape 21"/>
+          <p:cNvPr id="24" name="Shape 22"/>
           <p:cNvSpPr/>
           <p:nvPr/>
         </p:nvSpPr>
         <p:spPr>
           <a:xfrm>
-            <a:off x="4370832" y="3703320"/>
-            <a:ext cx="3429000" cy="2423160"/>
+            <a:off x="4370832" y="4069080"/>
+            <a:ext cx="3429000" cy="2103120"/>
           </a:xfrm>
           <a:prstGeom prst="roundRect">
             <a:avLst>
-              <a:gd name="adj" fmla="val 4528"/>
+              <a:gd name="adj" fmla="val 5217"/>
             </a:avLst>
           </a:prstGeom>
           <a:solidFill>
@@ -6930,13 +6949,13 @@
       </p:sp>
       <p:sp>
         <p:nvSpPr>
-          <p:cNvPr id="24" name="Text 22"/>
-          <p:cNvSpPr txBox="1"/>
-          <p:nvPr/>
-        </p:nvSpPr>
-        <p:spPr>
-          <a:xfrm>
-            <a:off x="4645152" y="3886200"/>
+          <p:cNvPr id="25" name="Text 23"/>
+          <p:cNvSpPr txBox="1"/>
+          <p:nvPr/>
+        </p:nvSpPr>
+        <p:spPr>
+          <a:xfrm>
+            <a:off x="4645152" y="4233672"/>
             <a:ext cx="2880360" cy="384048"/>
           </a:xfrm>
           <a:prstGeom prst="rect">
@@ -6969,14 +6988,14 @@
       </p:sp>
       <p:sp>
         <p:nvSpPr>
-          <p:cNvPr id="25" name="Text 23"/>
-          <p:cNvSpPr txBox="1"/>
-          <p:nvPr/>
-        </p:nvSpPr>
-        <p:spPr>
-          <a:xfrm>
-            <a:off x="4645152" y="4297680"/>
-            <a:ext cx="2880360" cy="777240"/>
+          <p:cNvPr id="26" name="Text 24"/>
+          <p:cNvSpPr txBox="1"/>
+          <p:nvPr/>
+        </p:nvSpPr>
+        <p:spPr>
+          <a:xfrm>
+            <a:off x="4645152" y="4617720"/>
+            <a:ext cx="2880360" cy="685800"/>
           </a:xfrm>
           <a:prstGeom prst="rect">
             <a:avLst/>
@@ -6992,7 +7011,7 @@
               <a:buNone/>
             </a:pPr>
             <a:r>
-              <a:rPr lang="en-US" sz="5400" b="1" dirty="0">
+              <a:rPr lang="en-US" sz="5000" b="1" dirty="0">
                 <a:solidFill>
                   <a:srgbClr val="DC2626"/>
                 </a:solidFill>
@@ -7002,20 +7021,20 @@
               </a:rPr>
               <a:t>0</a:t>
             </a:r>
-            <a:endParaRPr lang="en-US" sz="5400" dirty="0"/>
-          </a:p>
-        </p:txBody>
-      </p:sp>
-      <p:sp>
-        <p:nvSpPr>
-          <p:cNvPr id="26" name="Text 24"/>
-          <p:cNvSpPr txBox="1"/>
-          <p:nvPr/>
-        </p:nvSpPr>
-        <p:spPr>
-          <a:xfrm>
-            <a:off x="4645152" y="5074920"/>
-            <a:ext cx="2880360" cy="320040"/>
+            <a:endParaRPr lang="en-US" sz="5000" dirty="0"/>
+          </a:p>
+        </p:txBody>
+      </p:sp>
+      <p:sp>
+        <p:nvSpPr>
+          <p:cNvPr id="27" name="Text 25"/>
+          <p:cNvSpPr txBox="1"/>
+          <p:nvPr/>
+        </p:nvSpPr>
+        <p:spPr>
+          <a:xfrm>
+            <a:off x="4645152" y="5321808"/>
+            <a:ext cx="2880360" cy="301752"/>
           </a:xfrm>
           <a:prstGeom prst="rect">
             <a:avLst/>
@@ -7047,14 +7066,14 @@
       </p:sp>
       <p:sp>
         <p:nvSpPr>
-          <p:cNvPr id="27" name="Text 25"/>
-          <p:cNvSpPr txBox="1"/>
-          <p:nvPr/>
-        </p:nvSpPr>
-        <p:spPr>
-          <a:xfrm>
-            <a:off x="4645152" y="5394960"/>
-            <a:ext cx="2880360" cy="640080"/>
+          <p:cNvPr id="28" name="Text 26"/>
+          <p:cNvSpPr txBox="1"/>
+          <p:nvPr/>
+        </p:nvSpPr>
+        <p:spPr>
+          <a:xfrm>
+            <a:off x="4645152" y="5623560"/>
+            <a:ext cx="2880360" cy="502920"/>
           </a:xfrm>
           <a:prstGeom prst="rect">
             <a:avLst/>
@@ -7086,18 +7105,18 @@
       </p:sp>
       <p:sp>
         <p:nvSpPr>
-          <p:cNvPr id="28" name="Shape 26"/>
+          <p:cNvPr id="29" name="Shape 27"/>
           <p:cNvSpPr/>
           <p:nvPr/>
         </p:nvSpPr>
         <p:spPr>
           <a:xfrm>
-            <a:off x="8193024" y="3703320"/>
-            <a:ext cx="3429000" cy="2423160"/>
+            <a:off x="8193024" y="4069080"/>
+            <a:ext cx="3429000" cy="2103120"/>
           </a:xfrm>
           <a:prstGeom prst="roundRect">
             <a:avLst>
-              <a:gd name="adj" fmla="val 4528"/>
+              <a:gd name="adj" fmla="val 5217"/>
             </a:avLst>
           </a:prstGeom>
           <a:solidFill>
@@ -7113,13 +7132,13 @@
       </p:sp>
       <p:sp>
         <p:nvSpPr>
-          <p:cNvPr id="29" name="Text 27"/>
-          <p:cNvSpPr txBox="1"/>
-          <p:nvPr/>
-        </p:nvSpPr>
-        <p:spPr>
-          <a:xfrm>
-            <a:off x="8467344" y="3886200"/>
+          <p:cNvPr id="30" name="Text 28"/>
+          <p:cNvSpPr txBox="1"/>
+          <p:nvPr/>
+        </p:nvSpPr>
+        <p:spPr>
+          <a:xfrm>
+            <a:off x="8467344" y="4233672"/>
             <a:ext cx="2880360" cy="384048"/>
           </a:xfrm>
           <a:prstGeom prst="rect">
@@ -7152,14 +7171,14 @@
       </p:sp>
       <p:sp>
         <p:nvSpPr>
-          <p:cNvPr id="30" name="Text 28"/>
-          <p:cNvSpPr txBox="1"/>
-          <p:nvPr/>
-        </p:nvSpPr>
-        <p:spPr>
-          <a:xfrm>
-            <a:off x="8467344" y="4297680"/>
-            <a:ext cx="2880360" cy="777240"/>
+          <p:cNvPr id="31" name="Text 29"/>
+          <p:cNvSpPr txBox="1"/>
+          <p:nvPr/>
+        </p:nvSpPr>
+        <p:spPr>
+          <a:xfrm>
+            <a:off x="8467344" y="4617720"/>
+            <a:ext cx="2880360" cy="685800"/>
           </a:xfrm>
           <a:prstGeom prst="rect">
             <a:avLst/>
@@ -7191,14 +7210,14 @@
       </p:sp>
       <p:sp>
         <p:nvSpPr>
-          <p:cNvPr id="31" name="Text 29"/>
-          <p:cNvSpPr txBox="1"/>
-          <p:nvPr/>
-        </p:nvSpPr>
-        <p:spPr>
-          <a:xfrm>
-            <a:off x="8467344" y="5074920"/>
-            <a:ext cx="2880360" cy="320040"/>
+          <p:cNvPr id="32" name="Text 30"/>
+          <p:cNvSpPr txBox="1"/>
+          <p:nvPr/>
+        </p:nvSpPr>
+        <p:spPr>
+          <a:xfrm>
+            <a:off x="8467344" y="5321808"/>
+            <a:ext cx="2880360" cy="301752"/>
           </a:xfrm>
           <a:prstGeom prst="rect">
             <a:avLst/>
@@ -7230,14 +7249,14 @@
       </p:sp>
       <p:sp>
         <p:nvSpPr>
-          <p:cNvPr id="32" name="Text 30"/>
-          <p:cNvSpPr txBox="1"/>
-          <p:nvPr/>
-        </p:nvSpPr>
-        <p:spPr>
-          <a:xfrm>
-            <a:off x="8467344" y="5394960"/>
-            <a:ext cx="2880360" cy="640080"/>
+          <p:cNvPr id="33" name="Text 31"/>
+          <p:cNvSpPr txBox="1"/>
+          <p:nvPr/>
+        </p:nvSpPr>
+        <p:spPr>
+          <a:xfrm>
+            <a:off x="8467344" y="5623560"/>
+            <a:ext cx="2880360" cy="502920"/>
           </a:xfrm>
           <a:prstGeom prst="rect">
             <a:avLst/>
@@ -7269,7 +7288,7 @@
       </p:sp>
       <p:sp>
         <p:nvSpPr>
-          <p:cNvPr id="33" name="Text 31"/>
+          <p:cNvPr id="34" name="Text 32"/>
           <p:cNvSpPr txBox="1"/>
           <p:nvPr/>
         </p:nvSpPr>
@@ -8462,7 +8481,7 @@
         </p:nvSpPr>
         <p:spPr>
           <a:xfrm>
-            <a:off x="6446520" y="1874520"/>
+            <a:off x="6446520" y="1783080"/>
             <a:ext cx="548640" cy="548640"/>
           </a:xfrm>
           <a:prstGeom prst="ellipse">
@@ -8487,7 +8506,7 @@
         </p:nvSpPr>
         <p:spPr>
           <a:xfrm>
-            <a:off x="6446520" y="1874520"/>
+            <a:off x="6446520" y="1783080"/>
             <a:ext cx="548640" cy="548640"/>
           </a:xfrm>
           <a:prstGeom prst="rect">
@@ -8526,24 +8545,24 @@
         </p:nvSpPr>
         <p:spPr>
           <a:xfrm>
-            <a:off x="7223760" y="1856232"/>
-            <a:ext cx="4510735" cy="384048"/>
-          </a:xfrm>
-          <a:prstGeom prst="rect">
-            <a:avLst/>
-          </a:prstGeom>
-          <a:noFill/>
-          <a:ln/>
-        </p:spPr>
-        <p:txBody>
-          <a:bodyPr wrap="square" lIns="0" tIns="0" rIns="0" bIns="0" rtlCol="0" anchor="t"/>
-          <a:lstStyle/>
-          <a:p>
-            <a:pPr indent="0" marL="0">
-              <a:buNone/>
-            </a:pPr>
-            <a:r>
-              <a:rPr lang="en-US" sz="2000" b="1" dirty="0">
+            <a:off x="7223760" y="1746504"/>
+            <a:ext cx="4419295" cy="365760"/>
+          </a:xfrm>
+          <a:prstGeom prst="rect">
+            <a:avLst/>
+          </a:prstGeom>
+          <a:noFill/>
+          <a:ln/>
+        </p:spPr>
+        <p:txBody>
+          <a:bodyPr wrap="square" lIns="0" tIns="0" rIns="0" bIns="0" rtlCol="0" anchor="t"/>
+          <a:lstStyle/>
+          <a:p>
+            <a:pPr indent="0" marL="0">
+              <a:buNone/>
+            </a:pPr>
+            <a:r>
+              <a:rPr lang="en-US" sz="1900" b="1" dirty="0">
                 <a:solidFill>
                   <a:srgbClr val="161B22"/>
                 </a:solidFill>
@@ -8553,7 +8572,7 @@
               </a:rPr>
               <a:t>Clean</a:t>
             </a:r>
-            <a:endParaRPr lang="en-US" sz="2000" dirty="0"/>
+            <a:endParaRPr lang="en-US" sz="1900" dirty="0"/>
           </a:p>
         </p:txBody>
       </p:sp>
@@ -8565,8 +8584,8 @@
         </p:nvSpPr>
         <p:spPr>
           <a:xfrm>
-            <a:off x="7223760" y="2258568"/>
-            <a:ext cx="4510735" cy="914400"/>
+            <a:off x="7223760" y="2112264"/>
+            <a:ext cx="4419295" cy="658368"/>
           </a:xfrm>
           <a:prstGeom prst="rect">
             <a:avLst/>
@@ -8590,7 +8609,7 @@
                 <a:ea typeface="Calibri" pitchFamily="34" charset="-122"/>
                 <a:cs typeface="Calibri" pitchFamily="34" charset="-120"/>
               </a:rPr>
-              <a:t>Dates arrive as huge numbers - we turn them back into dates, in Sri Lanka time. Text that is really numbers becomes numbers.</a:t>
+              <a:t>Dates from huge numbers into Sri Lanka time, and text that is really numbers into numbers.</a:t>
             </a:r>
             <a:endParaRPr lang="en-US" sz="1500" dirty="0"/>
           </a:p>
@@ -8604,7 +8623,7 @@
         </p:nvSpPr>
         <p:spPr>
           <a:xfrm>
-            <a:off x="6446520" y="3291840"/>
+            <a:off x="6446520" y="2862072"/>
             <a:ext cx="548640" cy="548640"/>
           </a:xfrm>
           <a:prstGeom prst="ellipse">
@@ -8629,7 +8648,7 @@
         </p:nvSpPr>
         <p:spPr>
           <a:xfrm>
-            <a:off x="6446520" y="3291840"/>
+            <a:off x="6446520" y="2862072"/>
             <a:ext cx="548640" cy="548640"/>
           </a:xfrm>
           <a:prstGeom prst="rect">
@@ -8668,24 +8687,24 @@
         </p:nvSpPr>
         <p:spPr>
           <a:xfrm>
-            <a:off x="7223760" y="3273552"/>
-            <a:ext cx="4510735" cy="384048"/>
-          </a:xfrm>
-          <a:prstGeom prst="rect">
-            <a:avLst/>
-          </a:prstGeom>
-          <a:noFill/>
-          <a:ln/>
-        </p:spPr>
-        <p:txBody>
-          <a:bodyPr wrap="square" lIns="0" tIns="0" rIns="0" bIns="0" rtlCol="0" anchor="t"/>
-          <a:lstStyle/>
-          <a:p>
-            <a:pPr indent="0" marL="0">
-              <a:buNone/>
-            </a:pPr>
-            <a:r>
-              <a:rPr lang="en-US" sz="2000" b="1" dirty="0">
+            <a:off x="7223760" y="2825496"/>
+            <a:ext cx="4419295" cy="365760"/>
+          </a:xfrm>
+          <a:prstGeom prst="rect">
+            <a:avLst/>
+          </a:prstGeom>
+          <a:noFill/>
+          <a:ln/>
+        </p:spPr>
+        <p:txBody>
+          <a:bodyPr wrap="square" lIns="0" tIns="0" rIns="0" bIns="0" rtlCol="0" anchor="t"/>
+          <a:lstStyle/>
+          <a:p>
+            <a:pPr indent="0" marL="0">
+              <a:buNone/>
+            </a:pPr>
+            <a:r>
+              <a:rPr lang="en-US" sz="1900" b="1" dirty="0">
                 <a:solidFill>
                   <a:srgbClr val="161B22"/>
                 </a:solidFill>
@@ -8695,7 +8714,7 @@
               </a:rPr>
               <a:t>Check</a:t>
             </a:r>
-            <a:endParaRPr lang="en-US" sz="2000" dirty="0"/>
+            <a:endParaRPr lang="en-US" sz="1900" dirty="0"/>
           </a:p>
         </p:txBody>
       </p:sp>
@@ -8707,8 +8726,8 @@
         </p:nvSpPr>
         <p:spPr>
           <a:xfrm>
-            <a:off x="7223760" y="3675888"/>
-            <a:ext cx="4510735" cy="914400"/>
+            <a:off x="7223760" y="3191256"/>
+            <a:ext cx="4419295" cy="658368"/>
           </a:xfrm>
           <a:prstGeom prst="rect">
             <a:avLst/>
@@ -8732,7 +8751,7 @@
                 <a:ea typeface="Calibri" pitchFamily="34" charset="-122"/>
                 <a:cs typeface="Calibri" pitchFamily="34" charset="-120"/>
               </a:rPr>
-              <a:t>All 6 checks passed: no negative prices, no company twice, and 99.8% of cells have a value.</a:t>
+              <a:t>All 6 checks passed - no negative prices, no company twice, 99.8% of cells filled.</a:t>
             </a:r>
             <a:endParaRPr lang="en-US" sz="1500" dirty="0"/>
           </a:p>
@@ -8746,7 +8765,7 @@
         </p:nvSpPr>
         <p:spPr>
           <a:xfrm>
-            <a:off x="6446520" y="4709160"/>
+            <a:off x="6446520" y="3941064"/>
             <a:ext cx="548640" cy="548640"/>
           </a:xfrm>
           <a:prstGeom prst="ellipse">
@@ -8771,7 +8790,7 @@
         </p:nvSpPr>
         <p:spPr>
           <a:xfrm>
-            <a:off x="6446520" y="4709160"/>
+            <a:off x="6446520" y="3941064"/>
             <a:ext cx="548640" cy="548640"/>
           </a:xfrm>
           <a:prstGeom prst="rect">
@@ -8810,24 +8829,24 @@
         </p:nvSpPr>
         <p:spPr>
           <a:xfrm>
-            <a:off x="7223760" y="4690872"/>
-            <a:ext cx="4510735" cy="384048"/>
-          </a:xfrm>
-          <a:prstGeom prst="rect">
-            <a:avLst/>
-          </a:prstGeom>
-          <a:noFill/>
-          <a:ln/>
-        </p:spPr>
-        <p:txBody>
-          <a:bodyPr wrap="square" lIns="0" tIns="0" rIns="0" bIns="0" rtlCol="0" anchor="t"/>
-          <a:lstStyle/>
-          <a:p>
-            <a:pPr indent="0" marL="0">
-              <a:buNone/>
-            </a:pPr>
-            <a:r>
-              <a:rPr lang="en-US" sz="2000" b="1" dirty="0">
+            <a:off x="7223760" y="3904488"/>
+            <a:ext cx="4419295" cy="365760"/>
+          </a:xfrm>
+          <a:prstGeom prst="rect">
+            <a:avLst/>
+          </a:prstGeom>
+          <a:noFill/>
+          <a:ln/>
+        </p:spPr>
+        <p:txBody>
+          <a:bodyPr wrap="square" lIns="0" tIns="0" rIns="0" bIns="0" rtlCol="0" anchor="t"/>
+          <a:lstStyle/>
+          <a:p>
+            <a:pPr indent="0" marL="0">
+              <a:buNone/>
+            </a:pPr>
+            <a:r>
+              <a:rPr lang="en-US" sz="1900" b="1" dirty="0">
                 <a:solidFill>
                   <a:srgbClr val="161B22"/>
                 </a:solidFill>
@@ -8835,22 +8854,164 @@
                 <a:ea typeface="Calibri" pitchFamily="34" charset="-122"/>
                 <a:cs typeface="Calibri" pitchFamily="34" charset="-120"/>
               </a:rPr>
+              <a:t>Chart</a:t>
+            </a:r>
+            <a:endParaRPr lang="en-US" sz="1900" dirty="0"/>
+          </a:p>
+        </p:txBody>
+      </p:sp>
+      <p:sp>
+        <p:nvSpPr>
+          <p:cNvPr id="16" name="Text 13"/>
+          <p:cNvSpPr txBox="1"/>
+          <p:nvPr/>
+        </p:nvSpPr>
+        <p:spPr>
+          <a:xfrm>
+            <a:off x="7223760" y="4270248"/>
+            <a:ext cx="4419295" cy="658368"/>
+          </a:xfrm>
+          <a:prstGeom prst="rect">
+            <a:avLst/>
+          </a:prstGeom>
+          <a:noFill/>
+          <a:ln/>
+        </p:spPr>
+        <p:txBody>
+          <a:bodyPr wrap="square" lIns="0" tIns="0" rIns="0" bIns="0" rtlCol="0" anchor="t"/>
+          <a:lstStyle/>
+          <a:p>
+            <a:pPr indent="0" marL="0">
+              <a:buNone/>
+            </a:pPr>
+            <a:r>
+              <a:rPr lang="en-US" sz="1500" dirty="0">
+                <a:solidFill>
+                  <a:srgbClr val="57606A"/>
+                </a:solidFill>
+                <a:latin typeface="Calibri" pitchFamily="34" charset="0"/>
+                <a:ea typeface="Calibri" pitchFamily="34" charset="-122"/>
+                <a:cs typeface="Calibri" pitchFamily="34" charset="-120"/>
+              </a:rPr>
+              <a:t>Three charts in the app: the biggest movers, turnover, and the sectors.</a:t>
+            </a:r>
+            <a:endParaRPr lang="en-US" sz="1500" dirty="0"/>
+          </a:p>
+        </p:txBody>
+      </p:sp>
+      <p:sp>
+        <p:nvSpPr>
+          <p:cNvPr id="17" name="Shape 14"/>
+          <p:cNvSpPr/>
+          <p:nvPr/>
+        </p:nvSpPr>
+        <p:spPr>
+          <a:xfrm>
+            <a:off x="6446520" y="5020056"/>
+            <a:ext cx="548640" cy="548640"/>
+          </a:xfrm>
+          <a:prstGeom prst="ellipse">
+            <a:avLst/>
+          </a:prstGeom>
+          <a:solidFill>
+            <a:srgbClr val="0891B2"/>
+          </a:solidFill>
+          <a:ln w="12700">
+            <a:solidFill>
+              <a:srgbClr val="0891B2"/>
+            </a:solidFill>
+            <a:prstDash val="solid"/>
+          </a:ln>
+        </p:spPr>
+      </p:sp>
+      <p:sp>
+        <p:nvSpPr>
+          <p:cNvPr id="18" name="Text 15"/>
+          <p:cNvSpPr txBox="1"/>
+          <p:nvPr/>
+        </p:nvSpPr>
+        <p:spPr>
+          <a:xfrm>
+            <a:off x="6446520" y="5020056"/>
+            <a:ext cx="548640" cy="548640"/>
+          </a:xfrm>
+          <a:prstGeom prst="rect">
+            <a:avLst/>
+          </a:prstGeom>
+          <a:noFill/>
+          <a:ln/>
+        </p:spPr>
+        <p:txBody>
+          <a:bodyPr wrap="square" lIns="0" tIns="0" rIns="0" bIns="0" rtlCol="0" anchor="ctr"/>
+          <a:lstStyle/>
+          <a:p>
+            <a:pPr algn="ctr" indent="0" marL="0">
+              <a:buNone/>
+            </a:pPr>
+            <a:r>
+              <a:rPr lang="en-US" sz="1600" b="1" dirty="0">
+                <a:solidFill>
+                  <a:srgbClr val="FFFFFF"/>
+                </a:solidFill>
+                <a:latin typeface="Calibri" pitchFamily="34" charset="0"/>
+                <a:ea typeface="Calibri" pitchFamily="34" charset="-122"/>
+                <a:cs typeface="Calibri" pitchFamily="34" charset="-120"/>
+              </a:rPr>
+              <a:t>4</a:t>
+            </a:r>
+            <a:endParaRPr lang="en-US" sz="1600" dirty="0"/>
+          </a:p>
+        </p:txBody>
+      </p:sp>
+      <p:sp>
+        <p:nvSpPr>
+          <p:cNvPr id="19" name="Text 16"/>
+          <p:cNvSpPr txBox="1"/>
+          <p:nvPr/>
+        </p:nvSpPr>
+        <p:spPr>
+          <a:xfrm>
+            <a:off x="7223760" y="4983480"/>
+            <a:ext cx="4419295" cy="365760"/>
+          </a:xfrm>
+          <a:prstGeom prst="rect">
+            <a:avLst/>
+          </a:prstGeom>
+          <a:noFill/>
+          <a:ln/>
+        </p:spPr>
+        <p:txBody>
+          <a:bodyPr wrap="square" lIns="0" tIns="0" rIns="0" bIns="0" rtlCol="0" anchor="t"/>
+          <a:lstStyle/>
+          <a:p>
+            <a:pPr indent="0" marL="0">
+              <a:buNone/>
+            </a:pPr>
+            <a:r>
+              <a:rPr lang="en-US" sz="1900" b="1" dirty="0">
+                <a:solidFill>
+                  <a:srgbClr val="161B22"/>
+                </a:solidFill>
+                <a:latin typeface="Calibri" pitchFamily="34" charset="0"/>
+                <a:ea typeface="Calibri" pitchFamily="34" charset="-122"/>
+                <a:cs typeface="Calibri" pitchFamily="34" charset="-120"/>
+              </a:rPr>
               <a:t>Save</a:t>
             </a:r>
-            <a:endParaRPr lang="en-US" sz="2000" dirty="0"/>
-          </a:p>
-        </p:txBody>
-      </p:sp>
-      <p:sp>
-        <p:nvSpPr>
-          <p:cNvPr id="16" name="Text 13"/>
-          <p:cNvSpPr txBox="1"/>
-          <p:nvPr/>
-        </p:nvSpPr>
-        <p:spPr>
-          <a:xfrm>
-            <a:off x="7223760" y="5093208"/>
-            <a:ext cx="4510735" cy="914400"/>
+            <a:endParaRPr lang="en-US" sz="1900" dirty="0"/>
+          </a:p>
+        </p:txBody>
+      </p:sp>
+      <p:sp>
+        <p:nvSpPr>
+          <p:cNvPr id="20" name="Text 17"/>
+          <p:cNvSpPr txBox="1"/>
+          <p:nvPr/>
+        </p:nvSpPr>
+        <p:spPr>
+          <a:xfrm>
+            <a:off x="7223760" y="5349240"/>
+            <a:ext cx="4419295" cy="658368"/>
           </a:xfrm>
           <a:prstGeom prst="rect">
             <a:avLst/>
@@ -8874,7 +9035,7 @@
                 <a:ea typeface="Calibri" pitchFamily="34" charset="-122"/>
                 <a:cs typeface="Calibri" pitchFamily="34" charset="-120"/>
               </a:rPr>
-              <a:t>CSV, Excel and JSON - with the Colombo Stock Exchange credited inside every file.</a:t>
+              <a:t>CSV, Excel and JSON - with CSE credited inside every file.</a:t>
             </a:r>
             <a:endParaRPr lang="en-US" sz="1500" dirty="0"/>
           </a:p>
@@ -8882,7 +9043,7 @@
       </p:sp>
       <p:sp>
         <p:nvSpPr>
-          <p:cNvPr id="17" name="Text 14"/>
+          <p:cNvPr id="21" name="Text 18"/>
           <p:cNvSpPr txBox="1"/>
           <p:nvPr/>
         </p:nvSpPr>

</xml_diff>